<commit_message>
House style: no em dashes in published copy, checked by verify
- CLAUDE.md §12: no em dash anywhere in published copy, no en dash in X copy;
  §4.5 writing rules for X (rounded numbers, plain language, one "Who should
  care?" post with a takeaways card, no dash bullets, varied rhythm); §5 no
  bars on a truncated axis, use dot-and-interval
- renball_verify: style check on every run (--style-only to run it alone),
  selftest case, "plausible range (95%)" allowed as an interval level
- renball_chart_style.takeaways_card: four-audience card image for X
- Slide bullets and limitation-list markers are small squares, not dashes;
  methodology page titles and the slide viewer drop their em dashes
- Homepage copy without em dashes
- Project 03: interim pass over page, dashboard, methodology and deck
  (rewritten in full in the Project 03 rebuild)
- .gitignore: per-project build caches under data/.cache/

Co-Authored-By: Claude Opus 5.5 (1M context) <noreply@anthropic.com>
</commit_message>
<xml_diff>
--- a/projects/03-true-contributors/slides.pptx
+++ b/projects/03-true-contributors/slides.pptx
@@ -4751,7 +4751,7 @@
                 </a:solidFill>
                 <a:latin typeface="JetBrains Mono"/>
               </a:rPr>
-              <a:t>Brandt's profile — 25% scorer / 37% SCA1 / 39% SCA2 — is shared by no pure goalscorer.</a:t>
+              <a:t>Brandt's profile (25% scorer / 37% SCA1 / 39% SCA2) is shared by no pure goalscorer.</a:t>
             </a:r>
           </a:p>
         </p:txBody>
@@ -5036,7 +5036,7 @@
                 </a:solidFill>
                 <a:latin typeface="JetBrains Mono"/>
               </a:rPr>
-              <a:t>Top 10 EP/90, age ≤ 23, ≥ 500 minutes. Dim bars = under 2,000 minutes (low sample). Yamal sits #10 on 2,209 minutes at age 16.9 — real volume, not a cameo.</a:t>
+              <a:t>Top 10 EP/90, age ≤ 23, ≥ 500 minutes. Dim bars = under 2,000 minutes (low sample). Yamal sits #10 on 2,209 minutes at age 16.9, real volume, not a cameo.</a:t>
             </a:r>
           </a:p>
         </p:txBody>
@@ -5269,37 +5269,44 @@
       </p:sp>
       <p:sp>
         <p:nvSpPr>
-          <p:cNvPr id="6" name="TextBox 5"/>
-          <p:cNvSpPr txBox="1"/>
-          <p:nvPr/>
-        </p:nvSpPr>
-        <p:spPr>
-          <a:xfrm>
-            <a:off x="640080" y="1463040"/>
-            <a:ext cx="365760" cy="777240"/>
-          </a:xfrm>
-          <a:prstGeom prst="rect">
-            <a:avLst/>
-          </a:prstGeom>
-          <a:noFill/>
-        </p:spPr>
-        <p:txBody>
-          <a:bodyPr wrap="square" lIns="0" rIns="0" tIns="0" bIns="0" anchor="t">
-            <a:spAutoFit/>
-          </a:bodyPr>
-          <a:lstStyle/>
-          <a:p>
-            <a:pPr algn="l"/>
-            <a:r>
-              <a:rPr sz="2200" b="0" i="0">
-                <a:solidFill>
-                  <a:srgbClr val="C1FF72"/>
-                </a:solidFill>
-                <a:latin typeface="Instrument Serif"/>
-              </a:rPr>
-              <a:t>—</a:t>
-            </a:r>
-          </a:p>
+          <p:cNvPr id="6" name="Rectangle 5"/>
+          <p:cNvSpPr/>
+          <p:nvPr/>
+        </p:nvSpPr>
+        <p:spPr>
+          <a:xfrm>
+            <a:off x="685800" y="1618488"/>
+            <a:ext cx="82296" cy="82296"/>
+          </a:xfrm>
+          <a:prstGeom prst="rect">
+            <a:avLst/>
+          </a:prstGeom>
+          <a:solidFill>
+            <a:srgbClr val="C1FF72"/>
+          </a:solidFill>
+          <a:ln>
+            <a:noFill/>
+          </a:ln>
+          <a:effectLst/>
+        </p:spPr>
+        <p:style>
+          <a:lnRef idx="1">
+            <a:schemeClr val="accent1"/>
+          </a:lnRef>
+          <a:fillRef idx="3">
+            <a:schemeClr val="accent1"/>
+          </a:fillRef>
+          <a:effectRef idx="2">
+            <a:schemeClr val="accent1"/>
+          </a:effectRef>
+          <a:fontRef idx="minor">
+            <a:schemeClr val="lt1"/>
+          </a:fontRef>
+        </p:style>
+        <p:txBody>
+          <a:bodyPr rtlCol="0" anchor="ctr" lIns="0" rIns="0" tIns="0" bIns="0"/>
+          <a:lstStyle/>
+          <a:p/>
         </p:txBody>
       </p:sp>
       <p:sp>
@@ -5339,37 +5346,44 @@
       </p:sp>
       <p:sp>
         <p:nvSpPr>
-          <p:cNvPr id="8" name="TextBox 7"/>
-          <p:cNvSpPr txBox="1"/>
-          <p:nvPr/>
-        </p:nvSpPr>
-        <p:spPr>
-          <a:xfrm>
-            <a:off x="640080" y="2377440"/>
-            <a:ext cx="365760" cy="777240"/>
-          </a:xfrm>
-          <a:prstGeom prst="rect">
-            <a:avLst/>
-          </a:prstGeom>
-          <a:noFill/>
-        </p:spPr>
-        <p:txBody>
-          <a:bodyPr wrap="square" lIns="0" rIns="0" tIns="0" bIns="0" anchor="t">
-            <a:spAutoFit/>
-          </a:bodyPr>
-          <a:lstStyle/>
-          <a:p>
-            <a:pPr algn="l"/>
-            <a:r>
-              <a:rPr sz="2200" b="0" i="0">
-                <a:solidFill>
-                  <a:srgbClr val="C1FF72"/>
-                </a:solidFill>
-                <a:latin typeface="Instrument Serif"/>
-              </a:rPr>
-              <a:t>—</a:t>
-            </a:r>
-          </a:p>
+          <p:cNvPr id="8" name="Rectangle 7"/>
+          <p:cNvSpPr/>
+          <p:nvPr/>
+        </p:nvSpPr>
+        <p:spPr>
+          <a:xfrm>
+            <a:off x="685800" y="2532888"/>
+            <a:ext cx="82296" cy="82296"/>
+          </a:xfrm>
+          <a:prstGeom prst="rect">
+            <a:avLst/>
+          </a:prstGeom>
+          <a:solidFill>
+            <a:srgbClr val="C1FF72"/>
+          </a:solidFill>
+          <a:ln>
+            <a:noFill/>
+          </a:ln>
+          <a:effectLst/>
+        </p:spPr>
+        <p:style>
+          <a:lnRef idx="1">
+            <a:schemeClr val="accent1"/>
+          </a:lnRef>
+          <a:fillRef idx="3">
+            <a:schemeClr val="accent1"/>
+          </a:fillRef>
+          <a:effectRef idx="2">
+            <a:schemeClr val="accent1"/>
+          </a:effectRef>
+          <a:fontRef idx="minor">
+            <a:schemeClr val="lt1"/>
+          </a:fontRef>
+        </p:style>
+        <p:txBody>
+          <a:bodyPr rtlCol="0" anchor="ctr" lIns="0" rIns="0" tIns="0" bIns="0"/>
+          <a:lstStyle/>
+          <a:p/>
         </p:txBody>
       </p:sp>
       <p:sp>
@@ -5402,44 +5416,51 @@
                 </a:solidFill>
                 <a:latin typeface="DM Sans"/>
               </a:rPr>
-              <a:t>Recruitment: a player like Brandt — whose largest layer is the pass before the pass — is materially mis-valued by conventional output metrics.</a:t>
-            </a:r>
-          </a:p>
-        </p:txBody>
-      </p:sp>
-      <p:sp>
-        <p:nvSpPr>
-          <p:cNvPr id="10" name="TextBox 9"/>
-          <p:cNvSpPr txBox="1"/>
-          <p:nvPr/>
-        </p:nvSpPr>
-        <p:spPr>
-          <a:xfrm>
-            <a:off x="640080" y="3291840"/>
-            <a:ext cx="365760" cy="777240"/>
-          </a:xfrm>
-          <a:prstGeom prst="rect">
-            <a:avLst/>
-          </a:prstGeom>
-          <a:noFill/>
-        </p:spPr>
-        <p:txBody>
-          <a:bodyPr wrap="square" lIns="0" rIns="0" tIns="0" bIns="0" anchor="t">
-            <a:spAutoFit/>
-          </a:bodyPr>
-          <a:lstStyle/>
-          <a:p>
-            <a:pPr algn="l"/>
-            <a:r>
-              <a:rPr sz="2200" b="0" i="0">
-                <a:solidFill>
-                  <a:srgbClr val="C1FF72"/>
-                </a:solidFill>
-                <a:latin typeface="Instrument Serif"/>
-              </a:rPr>
-              <a:t>—</a:t>
-            </a:r>
-          </a:p>
+              <a:t>Recruitment: a player like Brandt, whose largest layer is the pass before the pass, is materially mis-valued by conventional output metrics.</a:t>
+            </a:r>
+          </a:p>
+        </p:txBody>
+      </p:sp>
+      <p:sp>
+        <p:nvSpPr>
+          <p:cNvPr id="10" name="Rectangle 9"/>
+          <p:cNvSpPr/>
+          <p:nvPr/>
+        </p:nvSpPr>
+        <p:spPr>
+          <a:xfrm>
+            <a:off x="685800" y="3447288"/>
+            <a:ext cx="82296" cy="82296"/>
+          </a:xfrm>
+          <a:prstGeom prst="rect">
+            <a:avLst/>
+          </a:prstGeom>
+          <a:solidFill>
+            <a:srgbClr val="C1FF72"/>
+          </a:solidFill>
+          <a:ln>
+            <a:noFill/>
+          </a:ln>
+          <a:effectLst/>
+        </p:spPr>
+        <p:style>
+          <a:lnRef idx="1">
+            <a:schemeClr val="accent1"/>
+          </a:lnRef>
+          <a:fillRef idx="3">
+            <a:schemeClr val="accent1"/>
+          </a:fillRef>
+          <a:effectRef idx="2">
+            <a:schemeClr val="accent1"/>
+          </a:effectRef>
+          <a:fontRef idx="minor">
+            <a:schemeClr val="lt1"/>
+          </a:fontRef>
+        </p:style>
+        <p:txBody>
+          <a:bodyPr rtlCol="0" anchor="ctr" lIns="0" rIns="0" tIns="0" bIns="0"/>
+          <a:lstStyle/>
+          <a:p/>
         </p:txBody>
       </p:sp>
       <p:sp>
@@ -5479,37 +5500,44 @@
       </p:sp>
       <p:sp>
         <p:nvSpPr>
-          <p:cNvPr id="12" name="TextBox 11"/>
-          <p:cNvSpPr txBox="1"/>
-          <p:nvPr/>
-        </p:nvSpPr>
-        <p:spPr>
-          <a:xfrm>
-            <a:off x="640080" y="4206240"/>
-            <a:ext cx="365760" cy="777240"/>
-          </a:xfrm>
-          <a:prstGeom prst="rect">
-            <a:avLst/>
-          </a:prstGeom>
-          <a:noFill/>
-        </p:spPr>
-        <p:txBody>
-          <a:bodyPr wrap="square" lIns="0" rIns="0" tIns="0" bIns="0" anchor="t">
-            <a:spAutoFit/>
-          </a:bodyPr>
-          <a:lstStyle/>
-          <a:p>
-            <a:pPr algn="l"/>
-            <a:r>
-              <a:rPr sz="2200" b="0" i="0">
-                <a:solidFill>
-                  <a:srgbClr val="C1FF72"/>
-                </a:solidFill>
-                <a:latin typeface="Instrument Serif"/>
-              </a:rPr>
-              <a:t>—</a:t>
-            </a:r>
-          </a:p>
+          <p:cNvPr id="12" name="Rectangle 11"/>
+          <p:cNvSpPr/>
+          <p:nvPr/>
+        </p:nvSpPr>
+        <p:spPr>
+          <a:xfrm>
+            <a:off x="685800" y="4361688"/>
+            <a:ext cx="82296" cy="82296"/>
+          </a:xfrm>
+          <a:prstGeom prst="rect">
+            <a:avLst/>
+          </a:prstGeom>
+          <a:solidFill>
+            <a:srgbClr val="C1FF72"/>
+          </a:solidFill>
+          <a:ln>
+            <a:noFill/>
+          </a:ln>
+          <a:effectLst/>
+        </p:spPr>
+        <p:style>
+          <a:lnRef idx="1">
+            <a:schemeClr val="accent1"/>
+          </a:lnRef>
+          <a:fillRef idx="3">
+            <a:schemeClr val="accent1"/>
+          </a:fillRef>
+          <a:effectRef idx="2">
+            <a:schemeClr val="accent1"/>
+          </a:effectRef>
+          <a:fontRef idx="minor">
+            <a:schemeClr val="lt1"/>
+          </a:fontRef>
+        </p:style>
+        <p:txBody>
+          <a:bodyPr rtlCol="0" anchor="ctr" lIns="0" rIns="0" tIns="0" bIns="0"/>
+          <a:lstStyle/>
+          <a:p/>
         </p:txBody>
       </p:sp>
       <p:sp>
@@ -5775,37 +5803,44 @@
       </p:sp>
       <p:sp>
         <p:nvSpPr>
-          <p:cNvPr id="6" name="TextBox 5"/>
-          <p:cNvSpPr txBox="1"/>
-          <p:nvPr/>
-        </p:nvSpPr>
-        <p:spPr>
-          <a:xfrm>
-            <a:off x="640080" y="1463040"/>
-            <a:ext cx="365760" cy="777240"/>
-          </a:xfrm>
-          <a:prstGeom prst="rect">
-            <a:avLst/>
-          </a:prstGeom>
-          <a:noFill/>
-        </p:spPr>
-        <p:txBody>
-          <a:bodyPr wrap="square" lIns="0" rIns="0" tIns="0" bIns="0" anchor="t">
-            <a:spAutoFit/>
-          </a:bodyPr>
-          <a:lstStyle/>
-          <a:p>
-            <a:pPr algn="l"/>
-            <a:r>
-              <a:rPr sz="2200" b="0" i="0">
-                <a:solidFill>
-                  <a:srgbClr val="C1FF72"/>
-                </a:solidFill>
-                <a:latin typeface="Instrument Serif"/>
-              </a:rPr>
-              <a:t>—</a:t>
-            </a:r>
-          </a:p>
+          <p:cNvPr id="6" name="Rectangle 5"/>
+          <p:cNvSpPr/>
+          <p:nvPr/>
+        </p:nvSpPr>
+        <p:spPr>
+          <a:xfrm>
+            <a:off x="685800" y="1618488"/>
+            <a:ext cx="82296" cy="82296"/>
+          </a:xfrm>
+          <a:prstGeom prst="rect">
+            <a:avLst/>
+          </a:prstGeom>
+          <a:solidFill>
+            <a:srgbClr val="C1FF72"/>
+          </a:solidFill>
+          <a:ln>
+            <a:noFill/>
+          </a:ln>
+          <a:effectLst/>
+        </p:spPr>
+        <p:style>
+          <a:lnRef idx="1">
+            <a:schemeClr val="accent1"/>
+          </a:lnRef>
+          <a:fillRef idx="3">
+            <a:schemeClr val="accent1"/>
+          </a:fillRef>
+          <a:effectRef idx="2">
+            <a:schemeClr val="accent1"/>
+          </a:effectRef>
+          <a:fontRef idx="minor">
+            <a:schemeClr val="lt1"/>
+          </a:fontRef>
+        </p:style>
+        <p:txBody>
+          <a:bodyPr rtlCol="0" anchor="ctr" lIns="0" rIns="0" tIns="0" bIns="0"/>
+          <a:lstStyle/>
+          <a:p/>
         </p:txBody>
       </p:sp>
       <p:sp>
@@ -5845,37 +5880,44 @@
       </p:sp>
       <p:sp>
         <p:nvSpPr>
-          <p:cNvPr id="8" name="TextBox 7"/>
-          <p:cNvSpPr txBox="1"/>
-          <p:nvPr/>
-        </p:nvSpPr>
-        <p:spPr>
-          <a:xfrm>
-            <a:off x="640080" y="2377440"/>
-            <a:ext cx="365760" cy="777240"/>
-          </a:xfrm>
-          <a:prstGeom prst="rect">
-            <a:avLst/>
-          </a:prstGeom>
-          <a:noFill/>
-        </p:spPr>
-        <p:txBody>
-          <a:bodyPr wrap="square" lIns="0" rIns="0" tIns="0" bIns="0" anchor="t">
-            <a:spAutoFit/>
-          </a:bodyPr>
-          <a:lstStyle/>
-          <a:p>
-            <a:pPr algn="l"/>
-            <a:r>
-              <a:rPr sz="2200" b="0" i="0">
-                <a:solidFill>
-                  <a:srgbClr val="C1FF72"/>
-                </a:solidFill>
-                <a:latin typeface="Instrument Serif"/>
-              </a:rPr>
-              <a:t>—</a:t>
-            </a:r>
-          </a:p>
+          <p:cNvPr id="8" name="Rectangle 7"/>
+          <p:cNvSpPr/>
+          <p:nvPr/>
+        </p:nvSpPr>
+        <p:spPr>
+          <a:xfrm>
+            <a:off x="685800" y="2532888"/>
+            <a:ext cx="82296" cy="82296"/>
+          </a:xfrm>
+          <a:prstGeom prst="rect">
+            <a:avLst/>
+          </a:prstGeom>
+          <a:solidFill>
+            <a:srgbClr val="C1FF72"/>
+          </a:solidFill>
+          <a:ln>
+            <a:noFill/>
+          </a:ln>
+          <a:effectLst/>
+        </p:spPr>
+        <p:style>
+          <a:lnRef idx="1">
+            <a:schemeClr val="accent1"/>
+          </a:lnRef>
+          <a:fillRef idx="3">
+            <a:schemeClr val="accent1"/>
+          </a:fillRef>
+          <a:effectRef idx="2">
+            <a:schemeClr val="accent1"/>
+          </a:effectRef>
+          <a:fontRef idx="minor">
+            <a:schemeClr val="lt1"/>
+          </a:fontRef>
+        </p:style>
+        <p:txBody>
+          <a:bodyPr rtlCol="0" anchor="ctr" lIns="0" rIns="0" tIns="0" bIns="0"/>
+          <a:lstStyle/>
+          <a:p/>
         </p:txBody>
       </p:sp>
       <p:sp>
@@ -5908,44 +5950,51 @@
                 </a:solidFill>
                 <a:latin typeface="DM Sans"/>
               </a:rPr>
-              <a:t>Credit caps at SCA2 — build-up beyond the pre-assist isn't captured.</a:t>
-            </a:r>
-          </a:p>
-        </p:txBody>
-      </p:sp>
-      <p:sp>
-        <p:nvSpPr>
-          <p:cNvPr id="10" name="TextBox 9"/>
-          <p:cNvSpPr txBox="1"/>
-          <p:nvPr/>
-        </p:nvSpPr>
-        <p:spPr>
-          <a:xfrm>
-            <a:off x="640080" y="3291840"/>
-            <a:ext cx="365760" cy="777240"/>
-          </a:xfrm>
-          <a:prstGeom prst="rect">
-            <a:avLst/>
-          </a:prstGeom>
-          <a:noFill/>
-        </p:spPr>
-        <p:txBody>
-          <a:bodyPr wrap="square" lIns="0" rIns="0" tIns="0" bIns="0" anchor="t">
-            <a:spAutoFit/>
-          </a:bodyPr>
-          <a:lstStyle/>
-          <a:p>
-            <a:pPr algn="l"/>
-            <a:r>
-              <a:rPr sz="2200" b="0" i="0">
-                <a:solidFill>
-                  <a:srgbClr val="C1FF72"/>
-                </a:solidFill>
-                <a:latin typeface="Instrument Serif"/>
-              </a:rPr>
-              <a:t>—</a:t>
-            </a:r>
-          </a:p>
+              <a:t>Credit caps at SCA2: build-up beyond the pre-assist isn't captured.</a:t>
+            </a:r>
+          </a:p>
+        </p:txBody>
+      </p:sp>
+      <p:sp>
+        <p:nvSpPr>
+          <p:cNvPr id="10" name="Rectangle 9"/>
+          <p:cNvSpPr/>
+          <p:nvPr/>
+        </p:nvSpPr>
+        <p:spPr>
+          <a:xfrm>
+            <a:off x="685800" y="3447288"/>
+            <a:ext cx="82296" cy="82296"/>
+          </a:xfrm>
+          <a:prstGeom prst="rect">
+            <a:avLst/>
+          </a:prstGeom>
+          <a:solidFill>
+            <a:srgbClr val="C1FF72"/>
+          </a:solidFill>
+          <a:ln>
+            <a:noFill/>
+          </a:ln>
+          <a:effectLst/>
+        </p:spPr>
+        <p:style>
+          <a:lnRef idx="1">
+            <a:schemeClr val="accent1"/>
+          </a:lnRef>
+          <a:fillRef idx="3">
+            <a:schemeClr val="accent1"/>
+          </a:fillRef>
+          <a:effectRef idx="2">
+            <a:schemeClr val="accent1"/>
+          </a:effectRef>
+          <a:fontRef idx="minor">
+            <a:schemeClr val="lt1"/>
+          </a:fontRef>
+        </p:style>
+        <p:txBody>
+          <a:bodyPr rtlCol="0" anchor="ctr" lIns="0" rIns="0" tIns="0" bIns="0"/>
+          <a:lstStyle/>
+          <a:p/>
         </p:txBody>
       </p:sp>
       <p:sp>
@@ -5985,37 +6034,44 @@
       </p:sp>
       <p:sp>
         <p:nvSpPr>
-          <p:cNvPr id="12" name="TextBox 11"/>
-          <p:cNvSpPr txBox="1"/>
-          <p:nvPr/>
-        </p:nvSpPr>
-        <p:spPr>
-          <a:xfrm>
-            <a:off x="640080" y="4206240"/>
-            <a:ext cx="365760" cy="777240"/>
-          </a:xfrm>
-          <a:prstGeom prst="rect">
-            <a:avLst/>
-          </a:prstGeom>
-          <a:noFill/>
-        </p:spPr>
-        <p:txBody>
-          <a:bodyPr wrap="square" lIns="0" rIns="0" tIns="0" bIns="0" anchor="t">
-            <a:spAutoFit/>
-          </a:bodyPr>
-          <a:lstStyle/>
-          <a:p>
-            <a:pPr algn="l"/>
-            <a:r>
-              <a:rPr sz="2200" b="0" i="0">
-                <a:solidFill>
-                  <a:srgbClr val="C1FF72"/>
-                </a:solidFill>
-                <a:latin typeface="Instrument Serif"/>
-              </a:rPr>
-              <a:t>—</a:t>
-            </a:r>
-          </a:p>
+          <p:cNvPr id="12" name="Rectangle 11"/>
+          <p:cNvSpPr/>
+          <p:nvPr/>
+        </p:nvSpPr>
+        <p:spPr>
+          <a:xfrm>
+            <a:off x="685800" y="4361688"/>
+            <a:ext cx="82296" cy="82296"/>
+          </a:xfrm>
+          <a:prstGeom prst="rect">
+            <a:avLst/>
+          </a:prstGeom>
+          <a:solidFill>
+            <a:srgbClr val="C1FF72"/>
+          </a:solidFill>
+          <a:ln>
+            <a:noFill/>
+          </a:ln>
+          <a:effectLst/>
+        </p:spPr>
+        <p:style>
+          <a:lnRef idx="1">
+            <a:schemeClr val="accent1"/>
+          </a:lnRef>
+          <a:fillRef idx="3">
+            <a:schemeClr val="accent1"/>
+          </a:fillRef>
+          <a:effectRef idx="2">
+            <a:schemeClr val="accent1"/>
+          </a:effectRef>
+          <a:fontRef idx="minor">
+            <a:schemeClr val="lt1"/>
+          </a:fontRef>
+        </p:style>
+        <p:txBody>
+          <a:bodyPr rtlCol="0" anchor="ctr" lIns="0" rIns="0" tIns="0" bIns="0"/>
+          <a:lstStyle/>
+          <a:p/>
         </p:txBody>
       </p:sp>
       <p:sp>
@@ -6048,44 +6104,51 @@
                 </a:solidFill>
                 <a:latin typeface="DM Sans"/>
               </a:rPr>
-              <a:t>No opinion on goalkeepers — the three credited touchpoints are ones GKs rarely occupy.</a:t>
-            </a:r>
-          </a:p>
-        </p:txBody>
-      </p:sp>
-      <p:sp>
-        <p:nvSpPr>
-          <p:cNvPr id="14" name="TextBox 13"/>
-          <p:cNvSpPr txBox="1"/>
-          <p:nvPr/>
-        </p:nvSpPr>
-        <p:spPr>
-          <a:xfrm>
-            <a:off x="640080" y="5120640"/>
-            <a:ext cx="365760" cy="777240"/>
-          </a:xfrm>
-          <a:prstGeom prst="rect">
-            <a:avLst/>
-          </a:prstGeom>
-          <a:noFill/>
-        </p:spPr>
-        <p:txBody>
-          <a:bodyPr wrap="square" lIns="0" rIns="0" tIns="0" bIns="0" anchor="t">
-            <a:spAutoFit/>
-          </a:bodyPr>
-          <a:lstStyle/>
-          <a:p>
-            <a:pPr algn="l"/>
-            <a:r>
-              <a:rPr sz="2200" b="0" i="0">
-                <a:solidFill>
-                  <a:srgbClr val="C1FF72"/>
-                </a:solidFill>
-                <a:latin typeface="Instrument Serif"/>
-              </a:rPr>
-              <a:t>—</a:t>
-            </a:r>
-          </a:p>
+              <a:t>No opinion on goalkeepers: the three credited touchpoints are ones GKs rarely occupy.</a:t>
+            </a:r>
+          </a:p>
+        </p:txBody>
+      </p:sp>
+      <p:sp>
+        <p:nvSpPr>
+          <p:cNvPr id="14" name="Rectangle 13"/>
+          <p:cNvSpPr/>
+          <p:nvPr/>
+        </p:nvSpPr>
+        <p:spPr>
+          <a:xfrm>
+            <a:off x="685800" y="5276088"/>
+            <a:ext cx="82296" cy="82296"/>
+          </a:xfrm>
+          <a:prstGeom prst="rect">
+            <a:avLst/>
+          </a:prstGeom>
+          <a:solidFill>
+            <a:srgbClr val="C1FF72"/>
+          </a:solidFill>
+          <a:ln>
+            <a:noFill/>
+          </a:ln>
+          <a:effectLst/>
+        </p:spPr>
+        <p:style>
+          <a:lnRef idx="1">
+            <a:schemeClr val="accent1"/>
+          </a:lnRef>
+          <a:fillRef idx="3">
+            <a:schemeClr val="accent1"/>
+          </a:fillRef>
+          <a:effectRef idx="2">
+            <a:schemeClr val="accent1"/>
+          </a:effectRef>
+          <a:fontRef idx="minor">
+            <a:schemeClr val="lt1"/>
+          </a:fontRef>
+        </p:style>
+        <p:txBody>
+          <a:bodyPr rtlCol="0" anchor="ctr" lIns="0" rIns="0" tIns="0" bIns="0"/>
+          <a:lstStyle/>
+          <a:p/>
         </p:txBody>
       </p:sp>
       <p:sp>
@@ -6580,7 +6643,7 @@
                 </a:solidFill>
                 <a:latin typeface="JetBrains Mono"/>
               </a:rPr>
-              <a:t>→ code/build.py        Python pipeline — project 02 framework + SCA2 enrichment</a:t>
+              <a:t>→ code/build.py        Python pipeline: project 02 framework + SCA2 enrichment</a:t>
             </a:r>
           </a:p>
         </p:txBody>
@@ -6720,7 +6783,7 @@
                 </a:solidFill>
                 <a:latin typeface="Instrument Serif"/>
               </a:rPr>
-              <a:t>TL;DR — three sentences</a:t>
+              <a:t>TL;DR: three sentences</a:t>
             </a:r>
           </a:p>
         </p:txBody>
@@ -6769,37 +6832,44 @@
       </p:sp>
       <p:sp>
         <p:nvSpPr>
-          <p:cNvPr id="6" name="TextBox 5"/>
-          <p:cNvSpPr txBox="1"/>
-          <p:nvPr/>
-        </p:nvSpPr>
-        <p:spPr>
-          <a:xfrm>
-            <a:off x="640080" y="1463040"/>
-            <a:ext cx="365760" cy="777240"/>
-          </a:xfrm>
-          <a:prstGeom prst="rect">
-            <a:avLst/>
-          </a:prstGeom>
-          <a:noFill/>
-        </p:spPr>
-        <p:txBody>
-          <a:bodyPr wrap="square" lIns="0" rIns="0" tIns="0" bIns="0" anchor="t">
-            <a:spAutoFit/>
-          </a:bodyPr>
-          <a:lstStyle/>
-          <a:p>
-            <a:pPr algn="l"/>
-            <a:r>
-              <a:rPr sz="2200" b="0" i="0">
-                <a:solidFill>
-                  <a:srgbClr val="C1FF72"/>
-                </a:solidFill>
-                <a:latin typeface="Instrument Serif"/>
-              </a:rPr>
-              <a:t>—</a:t>
-            </a:r>
-          </a:p>
+          <p:cNvPr id="6" name="Rectangle 5"/>
+          <p:cNvSpPr/>
+          <p:nvPr/>
+        </p:nvSpPr>
+        <p:spPr>
+          <a:xfrm>
+            <a:off x="685800" y="1618488"/>
+            <a:ext cx="82296" cy="82296"/>
+          </a:xfrm>
+          <a:prstGeom prst="rect">
+            <a:avLst/>
+          </a:prstGeom>
+          <a:solidFill>
+            <a:srgbClr val="C1FF72"/>
+          </a:solidFill>
+          <a:ln>
+            <a:noFill/>
+          </a:ln>
+          <a:effectLst/>
+        </p:spPr>
+        <p:style>
+          <a:lnRef idx="1">
+            <a:schemeClr val="accent1"/>
+          </a:lnRef>
+          <a:fillRef idx="3">
+            <a:schemeClr val="accent1"/>
+          </a:fillRef>
+          <a:effectRef idx="2">
+            <a:schemeClr val="accent1"/>
+          </a:effectRef>
+          <a:fontRef idx="minor">
+            <a:schemeClr val="lt1"/>
+          </a:fontRef>
+        </p:style>
+        <p:txBody>
+          <a:bodyPr rtlCol="0" anchor="ctr" lIns="0" rIns="0" tIns="0" bIns="0"/>
+          <a:lstStyle/>
+          <a:p/>
         </p:txBody>
       </p:sp>
       <p:sp>
@@ -6832,44 +6902,51 @@
                 </a:solidFill>
                 <a:latin typeface="DM Sans"/>
               </a:rPr>
-              <a:t>We take project 02's time-aware expected-points (EP) value function and credit a THIRD touchpoint per goal — the pre-assist (SCA2) — alongside the scorer and the assister.</a:t>
-            </a:r>
-          </a:p>
-        </p:txBody>
-      </p:sp>
-      <p:sp>
-        <p:nvSpPr>
-          <p:cNvPr id="8" name="TextBox 7"/>
-          <p:cNvSpPr txBox="1"/>
-          <p:nvPr/>
-        </p:nvSpPr>
-        <p:spPr>
-          <a:xfrm>
-            <a:off x="640080" y="2377440"/>
-            <a:ext cx="365760" cy="777240"/>
-          </a:xfrm>
-          <a:prstGeom prst="rect">
-            <a:avLst/>
-          </a:prstGeom>
-          <a:noFill/>
-        </p:spPr>
-        <p:txBody>
-          <a:bodyPr wrap="square" lIns="0" rIns="0" tIns="0" bIns="0" anchor="t">
-            <a:spAutoFit/>
-          </a:bodyPr>
-          <a:lstStyle/>
-          <a:p>
-            <a:pPr algn="l"/>
-            <a:r>
-              <a:rPr sz="2200" b="0" i="0">
-                <a:solidFill>
-                  <a:srgbClr val="C1FF72"/>
-                </a:solidFill>
-                <a:latin typeface="Instrument Serif"/>
-              </a:rPr>
-              <a:t>—</a:t>
-            </a:r>
-          </a:p>
+              <a:t>We take project 02's time-aware expected-points (EP) value function and credit a THIRD touchpoint per goal (the pre-assist, SCA2) alongside the scorer and the assister.</a:t>
+            </a:r>
+          </a:p>
+        </p:txBody>
+      </p:sp>
+      <p:sp>
+        <p:nvSpPr>
+          <p:cNvPr id="8" name="Rectangle 7"/>
+          <p:cNvSpPr/>
+          <p:nvPr/>
+        </p:nvSpPr>
+        <p:spPr>
+          <a:xfrm>
+            <a:off x="685800" y="2532888"/>
+            <a:ext cx="82296" cy="82296"/>
+          </a:xfrm>
+          <a:prstGeom prst="rect">
+            <a:avLst/>
+          </a:prstGeom>
+          <a:solidFill>
+            <a:srgbClr val="C1FF72"/>
+          </a:solidFill>
+          <a:ln>
+            <a:noFill/>
+          </a:ln>
+          <a:effectLst/>
+        </p:spPr>
+        <p:style>
+          <a:lnRef idx="1">
+            <a:schemeClr val="accent1"/>
+          </a:lnRef>
+          <a:fillRef idx="3">
+            <a:schemeClr val="accent1"/>
+          </a:fillRef>
+          <a:effectRef idx="2">
+            <a:schemeClr val="accent1"/>
+          </a:effectRef>
+          <a:fontRef idx="minor">
+            <a:schemeClr val="lt1"/>
+          </a:fontRef>
+        </p:style>
+        <p:txBody>
+          <a:bodyPr rtlCol="0" anchor="ctr" lIns="0" rIns="0" tIns="0" bIns="0"/>
+          <a:lstStyle/>
+          <a:p/>
         </p:txBody>
       </p:sp>
       <p:sp>
@@ -6902,44 +6979,51 @@
                 </a:solidFill>
                 <a:latin typeface="DM Sans"/>
               </a:rPr>
-              <a:t>Across 39,381 goals in six leagues and seven seasons, the per-90 board still leads with the consensus elite (Lionel Messi, 1.14 EP/90) — the framework clears the eye test before it surfaces surprises.</a:t>
-            </a:r>
-          </a:p>
-        </p:txBody>
-      </p:sp>
-      <p:sp>
-        <p:nvSpPr>
-          <p:cNvPr id="10" name="TextBox 9"/>
-          <p:cNvSpPr txBox="1"/>
-          <p:nvPr/>
-        </p:nvSpPr>
-        <p:spPr>
-          <a:xfrm>
-            <a:off x="640080" y="3291840"/>
-            <a:ext cx="365760" cy="777240"/>
-          </a:xfrm>
-          <a:prstGeom prst="rect">
-            <a:avLst/>
-          </a:prstGeom>
-          <a:noFill/>
-        </p:spPr>
-        <p:txBody>
-          <a:bodyPr wrap="square" lIns="0" rIns="0" tIns="0" bIns="0" anchor="t">
-            <a:spAutoFit/>
-          </a:bodyPr>
-          <a:lstStyle/>
-          <a:p>
-            <a:pPr algn="l"/>
-            <a:r>
-              <a:rPr sz="2200" b="0" i="0">
-                <a:solidFill>
-                  <a:srgbClr val="C1FF72"/>
-                </a:solidFill>
-                <a:latin typeface="Instrument Serif"/>
-              </a:rPr>
-              <a:t>—</a:t>
-            </a:r>
-          </a:p>
+              <a:t>Across 39,381 goals in six leagues and seven seasons, the per-90 board still leads with the consensus elite (Lionel Messi, 1.14 EP/90), the framework clears the eye test before it surfaces surprises.</a:t>
+            </a:r>
+          </a:p>
+        </p:txBody>
+      </p:sp>
+      <p:sp>
+        <p:nvSpPr>
+          <p:cNvPr id="10" name="Rectangle 9"/>
+          <p:cNvSpPr/>
+          <p:nvPr/>
+        </p:nvSpPr>
+        <p:spPr>
+          <a:xfrm>
+            <a:off x="685800" y="3447288"/>
+            <a:ext cx="82296" cy="82296"/>
+          </a:xfrm>
+          <a:prstGeom prst="rect">
+            <a:avLst/>
+          </a:prstGeom>
+          <a:solidFill>
+            <a:srgbClr val="C1FF72"/>
+          </a:solidFill>
+          <a:ln>
+            <a:noFill/>
+          </a:ln>
+          <a:effectLst/>
+        </p:spPr>
+        <p:style>
+          <a:lnRef idx="1">
+            <a:schemeClr val="accent1"/>
+          </a:lnRef>
+          <a:fillRef idx="3">
+            <a:schemeClr val="accent1"/>
+          </a:fillRef>
+          <a:effectRef idx="2">
+            <a:schemeClr val="accent1"/>
+          </a:effectRef>
+          <a:fontRef idx="minor">
+            <a:schemeClr val="lt1"/>
+          </a:fontRef>
+        </p:style>
+        <p:txBody>
+          <a:bodyPr rtlCol="0" anchor="ctr" lIns="0" rIns="0" tIns="0" bIns="0"/>
+          <a:lstStyle/>
+          <a:p/>
         </p:txBody>
       </p:sp>
       <p:sp>
@@ -6972,7 +7056,7 @@
                 </a:solidFill>
                 <a:latin typeface="DM Sans"/>
               </a:rPr>
-              <a:t>The marquee finding: Julian Brandt collects 40.93 EP from pre-assists alone — second in Europe only to Messi (51.69) — and 39% of his total value comes from that single layer.</a:t>
+              <a:t>The marquee finding: Julian Brandt collects 40.93 EP from pre-assists alone, second in Europe only to Messi (51.69), and 39% of his total value comes from that single layer.</a:t>
             </a:r>
           </a:p>
         </p:txBody>
@@ -7312,7 +7396,7 @@
                 </a:solidFill>
                 <a:latin typeface="DM Sans"/>
               </a:rPr>
-              <a:t>Puts the ball in the net. Always credited — the goal goes on his record.</a:t>
+              <a:t>Puts the ball in the net. Always credited: the goal goes on his record.</a:t>
             </a:r>
           </a:p>
         </p:txBody>
@@ -7452,7 +7536,7 @@
                 </a:solidFill>
                 <a:latin typeface="DM Sans"/>
               </a:rPr>
-              <a:t>The pass before the pass. Almost never credited — it disappears into the squad page.</a:t>
+              <a:t>The pass before the pass. Almost never credited: it disappears into the squad page.</a:t>
             </a:r>
           </a:p>
         </p:txBody>
@@ -8274,7 +8358,7 @@
                 </a:solidFill>
                 <a:latin typeface="DM Sans"/>
               </a:rPr>
-              <a:t>Inherits project 02's value function verbatim — a goal is priced by the swing in expected league points it produces, conditioned on game-state and minute.</a:t>
+              <a:t>Inherits project 02's value function verbatim: a goal is priced by the swing in expected league points it produces, conditioned on game-state and minute.</a:t>
             </a:r>
           </a:p>
         </p:txBody>
@@ -8309,7 +8393,7 @@
                 </a:solidFill>
                 <a:latin typeface="DM Sans"/>
               </a:rPr>
-              <a:t>Per-90 = (EP / minutes) × 90. Minutes come from FBref summary tables — Top-5 leagues only, so every per-90 board excludes Eredivisie.</a:t>
+              <a:t>Per-90 = (EP / minutes) × 90. Minutes come from FBref summary tables, Top-5 leagues only, so every per-90 board excludes Eredivisie.</a:t>
             </a:r>
           </a:p>
         </p:txBody>
@@ -8629,7 +8713,7 @@
                 </a:solidFill>
                 <a:latin typeface="JetBrains Mono"/>
               </a:rPr>
-              <a:t>Top 10 by EP/90, ≥ 1,000 minutes, Top-5 leagues. The consensus elite leads — which is the point. Recover what everyone knows before surfacing surprises.</a:t>
+              <a:t>Top 10 by EP/90, ≥ 1,000 minutes, Top-5 leagues. The consensus elite leads, which is the point. Recover what everyone knows before surfacing surprises.</a:t>
             </a:r>
           </a:p>
         </p:txBody>
@@ -8871,37 +8955,44 @@
       </p:sp>
       <p:sp>
         <p:nvSpPr>
-          <p:cNvPr id="6" name="TextBox 5"/>
-          <p:cNvSpPr txBox="1"/>
-          <p:nvPr/>
-        </p:nvSpPr>
-        <p:spPr>
-          <a:xfrm>
-            <a:off x="640080" y="1463040"/>
-            <a:ext cx="365760" cy="777240"/>
-          </a:xfrm>
-          <a:prstGeom prst="rect">
-            <a:avLst/>
-          </a:prstGeom>
-          <a:noFill/>
-        </p:spPr>
-        <p:txBody>
-          <a:bodyPr wrap="square" lIns="0" rIns="0" tIns="0" bIns="0" anchor="t">
-            <a:spAutoFit/>
-          </a:bodyPr>
-          <a:lstStyle/>
-          <a:p>
-            <a:pPr algn="l"/>
-            <a:r>
-              <a:rPr sz="2200" b="0" i="0">
-                <a:solidFill>
-                  <a:srgbClr val="C1FF72"/>
-                </a:solidFill>
-                <a:latin typeface="Instrument Serif"/>
-              </a:rPr>
-              <a:t>—</a:t>
-            </a:r>
-          </a:p>
+          <p:cNvPr id="6" name="Rectangle 5"/>
+          <p:cNvSpPr/>
+          <p:nvPr/>
+        </p:nvSpPr>
+        <p:spPr>
+          <a:xfrm>
+            <a:off x="685800" y="1618488"/>
+            <a:ext cx="82296" cy="82296"/>
+          </a:xfrm>
+          <a:prstGeom prst="rect">
+            <a:avLst/>
+          </a:prstGeom>
+          <a:solidFill>
+            <a:srgbClr val="C1FF72"/>
+          </a:solidFill>
+          <a:ln>
+            <a:noFill/>
+          </a:ln>
+          <a:effectLst/>
+        </p:spPr>
+        <p:style>
+          <a:lnRef idx="1">
+            <a:schemeClr val="accent1"/>
+          </a:lnRef>
+          <a:fillRef idx="3">
+            <a:schemeClr val="accent1"/>
+          </a:fillRef>
+          <a:effectRef idx="2">
+            <a:schemeClr val="accent1"/>
+          </a:effectRef>
+          <a:fontRef idx="minor">
+            <a:schemeClr val="lt1"/>
+          </a:fontRef>
+        </p:style>
+        <p:txBody>
+          <a:bodyPr rtlCol="0" anchor="ctr" lIns="0" rIns="0" tIns="0" bIns="0"/>
+          <a:lstStyle/>
+          <a:p/>
         </p:txBody>
       </p:sp>
       <p:sp>
@@ -8934,44 +9025,51 @@
                 </a:solidFill>
                 <a:latin typeface="DM Sans"/>
               </a:rPr>
-              <a:t>Re-run the same board with credits weighted 0.40 / 0.35 / 0.25 (scorer / SCA1 / SCA2) — EP only, the minutes threshold is unchanged.</a:t>
-            </a:r>
-          </a:p>
-        </p:txBody>
-      </p:sp>
-      <p:sp>
-        <p:nvSpPr>
-          <p:cNvPr id="8" name="TextBox 7"/>
-          <p:cNvSpPr txBox="1"/>
-          <p:nvPr/>
-        </p:nvSpPr>
-        <p:spPr>
-          <a:xfrm>
-            <a:off x="640080" y="2377440"/>
-            <a:ext cx="365760" cy="777240"/>
-          </a:xfrm>
-          <a:prstGeom prst="rect">
-            <a:avLst/>
-          </a:prstGeom>
-          <a:noFill/>
-        </p:spPr>
-        <p:txBody>
-          <a:bodyPr wrap="square" lIns="0" rIns="0" tIns="0" bIns="0" anchor="t">
-            <a:spAutoFit/>
-          </a:bodyPr>
-          <a:lstStyle/>
-          <a:p>
-            <a:pPr algn="l"/>
-            <a:r>
-              <a:rPr sz="2200" b="0" i="0">
-                <a:solidFill>
-                  <a:srgbClr val="C1FF72"/>
-                </a:solidFill>
-                <a:latin typeface="Instrument Serif"/>
-              </a:rPr>
-              <a:t>—</a:t>
-            </a:r>
-          </a:p>
+              <a:t>Re-run the same board with credits weighted 0.40 / 0.35 / 0.25 (scorer / SCA1 / SCA2). EP only; the minutes threshold is unchanged.</a:t>
+            </a:r>
+          </a:p>
+        </p:txBody>
+      </p:sp>
+      <p:sp>
+        <p:nvSpPr>
+          <p:cNvPr id="8" name="Rectangle 7"/>
+          <p:cNvSpPr/>
+          <p:nvPr/>
+        </p:nvSpPr>
+        <p:spPr>
+          <a:xfrm>
+            <a:off x="685800" y="2532888"/>
+            <a:ext cx="82296" cy="82296"/>
+          </a:xfrm>
+          <a:prstGeom prst="rect">
+            <a:avLst/>
+          </a:prstGeom>
+          <a:solidFill>
+            <a:srgbClr val="C1FF72"/>
+          </a:solidFill>
+          <a:ln>
+            <a:noFill/>
+          </a:ln>
+          <a:effectLst/>
+        </p:spPr>
+        <p:style>
+          <a:lnRef idx="1">
+            <a:schemeClr val="accent1"/>
+          </a:lnRef>
+          <a:fillRef idx="3">
+            <a:schemeClr val="accent1"/>
+          </a:fillRef>
+          <a:effectRef idx="2">
+            <a:schemeClr val="accent1"/>
+          </a:effectRef>
+          <a:fontRef idx="minor">
+            <a:schemeClr val="lt1"/>
+          </a:fontRef>
+        </p:style>
+        <p:txBody>
+          <a:bodyPr rtlCol="0" anchor="ctr" lIns="0" rIns="0" tIns="0" bIns="0"/>
+          <a:lstStyle/>
+          <a:p/>
         </p:txBody>
       </p:sp>
       <p:sp>
@@ -9011,37 +9109,44 @@
       </p:sp>
       <p:sp>
         <p:nvSpPr>
-          <p:cNvPr id="10" name="TextBox 9"/>
-          <p:cNvSpPr txBox="1"/>
-          <p:nvPr/>
-        </p:nvSpPr>
-        <p:spPr>
-          <a:xfrm>
-            <a:off x="640080" y="3291840"/>
-            <a:ext cx="365760" cy="777240"/>
-          </a:xfrm>
-          <a:prstGeom prst="rect">
-            <a:avLst/>
-          </a:prstGeom>
-          <a:noFill/>
-        </p:spPr>
-        <p:txBody>
-          <a:bodyPr wrap="square" lIns="0" rIns="0" tIns="0" bIns="0" anchor="t">
-            <a:spAutoFit/>
-          </a:bodyPr>
-          <a:lstStyle/>
-          <a:p>
-            <a:pPr algn="l"/>
-            <a:r>
-              <a:rPr sz="2200" b="0" i="0">
-                <a:solidFill>
-                  <a:srgbClr val="C1FF72"/>
-                </a:solidFill>
-                <a:latin typeface="Instrument Serif"/>
-              </a:rPr>
-              <a:t>—</a:t>
-            </a:r>
-          </a:p>
+          <p:cNvPr id="10" name="Rectangle 9"/>
+          <p:cNvSpPr/>
+          <p:nvPr/>
+        </p:nvSpPr>
+        <p:spPr>
+          <a:xfrm>
+            <a:off x="685800" y="3447288"/>
+            <a:ext cx="82296" cy="82296"/>
+          </a:xfrm>
+          <a:prstGeom prst="rect">
+            <a:avLst/>
+          </a:prstGeom>
+          <a:solidFill>
+            <a:srgbClr val="C1FF72"/>
+          </a:solidFill>
+          <a:ln>
+            <a:noFill/>
+          </a:ln>
+          <a:effectLst/>
+        </p:spPr>
+        <p:style>
+          <a:lnRef idx="1">
+            <a:schemeClr val="accent1"/>
+          </a:lnRef>
+          <a:fillRef idx="3">
+            <a:schemeClr val="accent1"/>
+          </a:fillRef>
+          <a:effectRef idx="2">
+            <a:schemeClr val="accent1"/>
+          </a:effectRef>
+          <a:fontRef idx="minor">
+            <a:schemeClr val="lt1"/>
+          </a:fontRef>
+        </p:style>
+        <p:txBody>
+          <a:bodyPr rtlCol="0" anchor="ctr" lIns="0" rIns="0" tIns="0" bIns="0"/>
+          <a:lstStyle/>
+          <a:p/>
         </p:txBody>
       </p:sp>
       <p:sp>
@@ -9081,37 +9186,44 @@
       </p:sp>
       <p:sp>
         <p:nvSpPr>
-          <p:cNvPr id="12" name="TextBox 11"/>
-          <p:cNvSpPr txBox="1"/>
-          <p:nvPr/>
-        </p:nvSpPr>
-        <p:spPr>
-          <a:xfrm>
-            <a:off x="640080" y="4206240"/>
-            <a:ext cx="365760" cy="777240"/>
-          </a:xfrm>
-          <a:prstGeom prst="rect">
-            <a:avLst/>
-          </a:prstGeom>
-          <a:noFill/>
-        </p:spPr>
-        <p:txBody>
-          <a:bodyPr wrap="square" lIns="0" rIns="0" tIns="0" bIns="0" anchor="t">
-            <a:spAutoFit/>
-          </a:bodyPr>
-          <a:lstStyle/>
-          <a:p>
-            <a:pPr algn="l"/>
-            <a:r>
-              <a:rPr sz="2200" b="0" i="0">
-                <a:solidFill>
-                  <a:srgbClr val="C1FF72"/>
-                </a:solidFill>
-                <a:latin typeface="Instrument Serif"/>
-              </a:rPr>
-              <a:t>—</a:t>
-            </a:r>
-          </a:p>
+          <p:cNvPr id="12" name="Rectangle 11"/>
+          <p:cNvSpPr/>
+          <p:nvPr/>
+        </p:nvSpPr>
+        <p:spPr>
+          <a:xfrm>
+            <a:off x="685800" y="4361688"/>
+            <a:ext cx="82296" cy="82296"/>
+          </a:xfrm>
+          <a:prstGeom prst="rect">
+            <a:avLst/>
+          </a:prstGeom>
+          <a:solidFill>
+            <a:srgbClr val="C1FF72"/>
+          </a:solidFill>
+          <a:ln>
+            <a:noFill/>
+          </a:ln>
+          <a:effectLst/>
+        </p:spPr>
+        <p:style>
+          <a:lnRef idx="1">
+            <a:schemeClr val="accent1"/>
+          </a:lnRef>
+          <a:fillRef idx="3">
+            <a:schemeClr val="accent1"/>
+          </a:fillRef>
+          <a:effectRef idx="2">
+            <a:schemeClr val="accent1"/>
+          </a:effectRef>
+          <a:fontRef idx="minor">
+            <a:schemeClr val="lt1"/>
+          </a:fontRef>
+        </p:style>
+        <p:txBody>
+          <a:bodyPr rtlCol="0" anchor="ctr" lIns="0" rIns="0" tIns="0" bIns="0"/>
+          <a:lstStyle/>
+          <a:p/>
         </p:txBody>
       </p:sp>
       <p:sp>
@@ -9144,7 +9256,7 @@
                 </a:solidFill>
                 <a:latin typeface="DM Sans"/>
               </a:rPr>
-              <a:t>That the tuned weights reproduce the simple 1/1/1 board IS the result — the ranking is not an artefact of the credit split.</a:t>
+              <a:t>That the tuned weights reproduce the simple 1/1/1 board IS the result: the ranking is not an artefact of the credit split.</a:t>
             </a:r>
           </a:p>
         </p:txBody>
@@ -9705,7 +9817,7 @@
                 <a:latin typeface="DM Sans"/>
               </a:rPr>
               <a:t>Atalanta · 1.605 EP/90 (43 credits).
-The model's Ballon d'Or pick that season — not what the trophy cabinet recorded.</a:t>
+The model's Ballon d'Or pick that season, not what the trophy cabinet recorded.</a:t>
             </a:r>
           </a:p>
         </p:txBody>
@@ -9740,7 +9852,7 @@
                 </a:solidFill>
                 <a:latin typeface="JetBrains Mono"/>
               </a:rPr>
-              <a:t>Model's top EP/90 pick per (league × season) vs the real award winner — matched in 11 of 40 cells (28%). The model prices leverage, not reputation. Top-5 only.</a:t>
+              <a:t>Model's top EP/90 pick per (league × season) vs the real award winner, matched in 11 of 40 cells (28%). The model prices leverage, not reputation. Top-5 only.</a:t>
             </a:r>
           </a:p>
         </p:txBody>
@@ -11079,7 +11191,7 @@
                 </a:solidFill>
                 <a:latin typeface="JetBrains Mono"/>
               </a:rPr>
-              <a:t>Top EP/90 per modal position, ≥ 1,000 minutes. GK excluded — a structural blind spot of the framework (top GK ~0.1 EP/90 vs ~1.1 for forwards). De Bruyne is the most-sampled elite pick anywhere here: 14,674 minutes, 206 credits.</a:t>
+              <a:t>Top EP/90 per modal position, ≥ 1,000 minutes. GK excluded: a structural blind spot of the framework (top GK ~0.1 EP/90 vs ~1.1 for forwards). De Bruyne is the most-sampled elite pick anywhere here: 14,674 minutes, 206 credits.</a:t>
             </a:r>
           </a:p>
         </p:txBody>

</xml_diff>